<commit_message>
Add official PS ID/title/organization; reframe pitch for PS alignment
Official SIH details confirmed: PS ID SIH26171, "On-device Visual
Perception for Light-weight Browser Agents", organization ISRO. Added
Organization as a new line on slide 1 alongside the existing fields.

The official title is specifically about visual/pixel-level perception,
but the prototype and prior pitch wording described only DOM/regex-based
detection with no vision component at all - a real alignment gap against
the assigned problem statement, not just a nice-to-have. Reframed slide 2's
proposed-solution bullet and slide 3's Detection bullet to explicitly name
the current approach as "on-device screen perception via structural DOM
analysis" (a lightweight alternative to pixel-level vision), and added a
vision-model upgrade path (a small ViT) to slide 4's roadmap - wording only,
no implementation claims that outrun the actual prototype.

Co-Authored-By: Claude Sonnet 5 <noreply@anthropic.com>
</commit_message>
<xml_diff>
--- a/Final SIH 2026 (1).pptx
+++ b/Final SIH 2026 (1).pptx
@@ -5652,7 +5652,7 @@
                 <a:latin typeface="Calibri" panose="020B0604020202020204" pitchFamily="34" charset="0"/>
                 <a:cs typeface="Arial" panose="020B0604020202020204" pitchFamily="34" charset="0"/>
               </a:rPr>
-              <a:t>Problem Statement ID –</a:t>
+              <a:t>Problem Statement ID – SIH26171</a:t>
             </a:r>
           </a:p>
           <a:p>
@@ -5680,7 +5680,35 @@
               <a:rPr sz="1600" b="0" dirty="0">
                 <a:latin typeface="Calibri"/>
               </a:rPr>
-              <a:t>Privacy-preserving AI browser agent that can understand and act on web pages without exposing sensitive user data</a:t>
+              <a:t>On-device Visual Perception for Light-weight Browser Agents</a:t>
+            </a:r>
+          </a:p>
+          <a:p>
+            <a:pPr marL="285750" indent="-285750" algn="just">
+              <a:lnSpc>
+                <a:spcPct val="150000"/>
+              </a:lnSpc>
+              <a:buFont typeface="Arial" panose="020B0604020202020204" pitchFamily="34" charset="0"/>
+              <a:buChar char="•"/>
+            </a:pPr>
+            <a:r>
+              <a:rPr lang="en-US" sz="2400" b="1" dirty="0">
+                <a:latin typeface="Calibri" panose="020B0604020202020204" pitchFamily="34" charset="0"/>
+                <a:cs typeface="Arial" panose="020B0604020202020204" pitchFamily="34" charset="0"/>
+              </a:rPr>
+              <a:t>Organization -</a:t>
+            </a:r>
+            <a:r>
+              <a:rPr sz="1200" b="0" dirty="0">
+                <a:latin typeface="Calibri"/>
+              </a:rPr>
+              <a:t> </a:t>
+            </a:r>
+            <a:r>
+              <a:rPr sz="1600" b="0" dirty="0">
+                <a:latin typeface="Calibri"/>
+              </a:rPr>
+              <a:t>Indian Space Research Organisation (ISRO)</a:t>
             </a:r>
           </a:p>
           <a:p>
@@ -6076,7 +6104,7 @@
               <a:rPr sz="1300" b="0" dirty="0">
                 <a:latin typeface="Calibri"/>
               </a:rPr>
-              <a:t>• Scans any web page's DOM, detects sensitive fields (passwords, OTP, Aadhaar/PAN-like IDs, card numbers, email, phone, name, address, hidden tokens) entirely on-device</a:t>
+              <a:t>• Implements on-device screen perception via structural DOM analysis (a lightweight, fast alternative to pixel-level vision for structured web forms) — detects sensitive fields (passwords, OTP, Aadhaar/PAN-like IDs, card numbers, email, phone, name, address, hidden tokens) entirely on-device</a:t>
             </a:r>
           </a:p>
           <a:p>
@@ -6849,7 +6877,7 @@
               <a:rPr sz="1400" b="0" dirty="0">
                 <a:latin typeface="Calibri"/>
               </a:rPr>
-              <a:t>• Detection: regex pattern matching + DOM label/placeholder heuristics (no heavy ML libraries needed server-side)</a:t>
+              <a:t>• Detection: on-device screen perception via regex pattern matching + DOM label/placeholder heuristics (a lightweight, structural alternative to pixel-level vision models — no heavy ML libraries needed server-side)</a:t>
             </a:r>
           </a:p>
           <a:p>
@@ -7522,55 +7550,7 @@
               <a:rPr sz="1500" b="0" dirty="0">
                 <a:latin typeface="+mn-lt"/>
               </a:rPr>
-              <a:t>• Roadmap: real NER models for name/address, checksum validation (</a:t>
-            </a:r>
-            <a:r>
-              <a:rPr sz="1500" b="0" dirty="0" err="1">
-                <a:latin typeface="+mn-lt"/>
-              </a:rPr>
-              <a:t>Luhn</a:t>
-            </a:r>
-            <a:r>
-              <a:rPr sz="1500" b="0" dirty="0">
-                <a:latin typeface="+mn-lt"/>
-              </a:rPr>
-              <a:t>, </a:t>
-            </a:r>
-            <a:r>
-              <a:rPr sz="1500" b="0" dirty="0" err="1">
-                <a:latin typeface="+mn-lt"/>
-              </a:rPr>
-              <a:t>Aadhaar</a:t>
-            </a:r>
-            <a:r>
-              <a:rPr sz="1500" b="0" dirty="0">
-                <a:latin typeface="+mn-lt"/>
-              </a:rPr>
-              <a:t> </a:t>
-            </a:r>
-            <a:r>
-              <a:rPr sz="1500" b="0" dirty="0" err="1">
-                <a:latin typeface="+mn-lt"/>
-              </a:rPr>
-              <a:t>Verhoeff</a:t>
-            </a:r>
-            <a:r>
-              <a:rPr sz="1500" b="0" dirty="0">
-                <a:latin typeface="+mn-lt"/>
-              </a:rPr>
-              <a:t>), add </a:t>
-            </a:r>
-            <a:r>
-              <a:rPr sz="1500" b="0" dirty="0" err="1">
-                <a:latin typeface="+mn-lt"/>
-              </a:rPr>
-              <a:t>auth</a:t>
-            </a:r>
-            <a:r>
-              <a:rPr sz="1500" b="0" dirty="0">
-                <a:latin typeface="+mn-lt"/>
-              </a:rPr>
-              <a:t> for non-local deployment</a:t>
+              <a:t>• Roadmap: upgrade on-device perception from structural DOM analysis to a lightweight local vision model (e.g. a small ViT) for pixel-level screen understanding, plus real NER for name/address, checksum validation (Luhn, Aadhaar Verhoeff), and auth for non-local deployment</a:t>
             </a:r>
           </a:p>
         </p:txBody>

</xml_diff>